<commit_message>
style(seg4-slides): 封面/finale 對齊 01·03 白底慣例(不再用 midnight)
使用者要求視覺與現有各段投影片一致。原 04 封面/收尾用了 midnight,跟
01/02/03 的白底封面不一致。改成:
- 封面:白底 + violet 短條 + 「第四講」kicker + 大黑標題「動手做」+ violet 副標
  + violet pastel hook 卡 + 「范耀中 Yao-Chung Fan / 國立中興大學…」署名(套 03 版位)
- finale:白底三卡(連上世界 / 更真實的工具 / 親手造一支)+ 底部橋接 callout 到
  Segment 5(對齊 03 結尾的三卡 + bridge 慣例)
內容頁原本就用共用 lib_newstyle,維持不變。
</commit_message>
<xml_diff>
--- a/slides/04-hands-on-lab.pptx
+++ b/slides/04-hands-on-lab.pptx
@@ -3115,7 +3115,7 @@
             <a:avLst/>
           </a:prstGeom>
           <a:solidFill>
-            <a:srgbClr val="0F1429"/>
+            <a:srgbClr val="FFFFFF"/>
           </a:solidFill>
           <a:ln>
             <a:noFill/>
@@ -3151,8 +3151,8 @@
         </p:nvSpPr>
         <p:spPr>
           <a:xfrm>
-            <a:off x="0" y="2057400"/>
-            <a:ext cx="9143771" cy="41148"/>
+            <a:off x="582930" y="377190"/>
+            <a:ext cx="377190" cy="48006"/>
           </a:xfrm>
           <a:prstGeom prst="rect">
             <a:avLst/>
@@ -3195,8 +3195,8 @@
         </p:nvSpPr>
         <p:spPr>
           <a:xfrm>
-            <a:off x="617220" y="480059"/>
-            <a:ext cx="7543800" cy="342900"/>
+            <a:off x="582930" y="514350"/>
+            <a:ext cx="8229600" cy="274320"/>
           </a:xfrm>
           <a:prstGeom prst="rect">
             <a:avLst/>
@@ -3217,7 +3217,7 @@
                 </a:solidFill>
                 <a:latin typeface="Calibri"/>
               </a:rPr>
-              <a:t>SEGMENT 4 · HANDS-ON · 70 MIN</a:t>
+              <a:t>MCP 入門工作坊  ·  第四講</a:t>
             </a:r>
           </a:p>
         </p:txBody>
@@ -3230,8 +3230,8 @@
         </p:nvSpPr>
         <p:spPr>
           <a:xfrm>
-            <a:off x="582930" y="1303019"/>
-            <a:ext cx="7955279" cy="685800"/>
+            <a:off x="582930" y="1371600"/>
+            <a:ext cx="8229600" cy="1097280"/>
           </a:xfrm>
           <a:prstGeom prst="rect">
             <a:avLst/>
@@ -3246,13 +3246,13 @@
           <a:p>
             <a:pPr algn="l"/>
             <a:r>
-              <a:rPr sz="3750" b="1" i="0">
-                <a:solidFill>
-                  <a:srgbClr val="FFFFFF"/>
+              <a:rPr sz="6000" b="1" i="0">
+                <a:solidFill>
+                  <a:srgbClr val="1F2937"/>
                 </a:solidFill>
                 <a:latin typeface="Arial Black"/>
               </a:rPr>
-              <a:t>動手做：一個能力的誕生</a:t>
+              <a:t>動手做</a:t>
             </a:r>
           </a:p>
         </p:txBody>
@@ -3265,8 +3265,8 @@
         </p:nvSpPr>
         <p:spPr>
           <a:xfrm>
-            <a:off x="651509" y="2263139"/>
-            <a:ext cx="7543800" cy="411479"/>
+            <a:off x="582930" y="2434589"/>
+            <a:ext cx="8229600" cy="480059"/>
           </a:xfrm>
           <a:prstGeom prst="rect">
             <a:avLst/>
@@ -3281,83 +3281,201 @@
           <a:p>
             <a:pPr algn="l"/>
             <a:r>
-              <a:rPr sz="1650" b="0" i="1">
+              <a:rPr sz="1800" b="1" i="0">
+                <a:solidFill>
+                  <a:srgbClr val="7B5CF5"/>
+                </a:solidFill>
+                <a:latin typeface="Calibri"/>
+              </a:rPr>
+              <a:t>一個能力的誕生 —— 把 AI 能力從「無」變到「有」</a:t>
+            </a:r>
+          </a:p>
+        </p:txBody>
+      </p:sp>
+      <p:sp>
+        <p:nvSpPr>
+          <p:cNvPr id="7" name="Rounded Rectangle 6"/>
+          <p:cNvSpPr/>
+          <p:nvPr/>
+        </p:nvSpPr>
+        <p:spPr>
+          <a:xfrm>
+            <a:off x="582930" y="2983229"/>
+            <a:ext cx="5486400" cy="788669"/>
+          </a:xfrm>
+          <a:prstGeom prst="roundRect">
+            <a:avLst>
+              <a:gd name="adj" fmla="val 10000"/>
+            </a:avLst>
+          </a:prstGeom>
+          <a:solidFill>
+            <a:srgbClr val="EEE8FF"/>
+          </a:solidFill>
+          <a:ln w="19050">
+            <a:solidFill>
+              <a:srgbClr val="7B5CF5"/>
+            </a:solidFill>
+          </a:ln>
+          <a:effectLst/>
+        </p:spPr>
+        <p:style>
+          <a:lnRef idx="1">
+            <a:schemeClr val="accent1"/>
+          </a:lnRef>
+          <a:fillRef idx="3">
+            <a:schemeClr val="accent1"/>
+          </a:fillRef>
+          <a:effectRef idx="2">
+            <a:schemeClr val="accent1"/>
+          </a:effectRef>
+          <a:fontRef idx="minor">
+            <a:schemeClr val="lt1"/>
+          </a:fontRef>
+        </p:style>
+        <p:txBody>
+          <a:bodyPr rtlCol="0" anchor="ctr"/>
+          <a:lstStyle/>
+          <a:p>
+            <a:pPr algn="ctr"/>
+          </a:p>
+        </p:txBody>
+      </p:sp>
+      <p:sp>
+        <p:nvSpPr>
+          <p:cNvPr id="8" name="TextBox 7"/>
+          <p:cNvSpPr txBox="1"/>
+          <p:nvPr/>
+        </p:nvSpPr>
+        <p:spPr>
+          <a:xfrm>
+            <a:off x="754380" y="3051810"/>
+            <a:ext cx="5143500" cy="377190"/>
+          </a:xfrm>
+          <a:prstGeom prst="rect">
+            <a:avLst/>
+          </a:prstGeom>
+          <a:noFill/>
+        </p:spPr>
+        <p:txBody>
+          <a:bodyPr wrap="square" lIns="27432" rIns="27432" tIns="13716" bIns="13716" anchor="t">
+            <a:spAutoFit/>
+          </a:bodyPr>
+          <a:lstStyle/>
+          <a:p>
+            <a:pPr algn="l"/>
+            <a:r>
+              <a:rPr sz="1650" b="1" i="0">
+                <a:solidFill>
+                  <a:srgbClr val="5B3ED9"/>
+                </a:solidFill>
+                <a:latin typeface="Arial Black"/>
+              </a:rPr>
+              <a:t>投影片講概念  ·  Colab 現場做</a:t>
+            </a:r>
+          </a:p>
+        </p:txBody>
+      </p:sp>
+      <p:sp>
+        <p:nvSpPr>
+          <p:cNvPr id="9" name="TextBox 8"/>
+          <p:cNvSpPr txBox="1"/>
+          <p:nvPr/>
+        </p:nvSpPr>
+        <p:spPr>
+          <a:xfrm>
+            <a:off x="754380" y="3429000"/>
+            <a:ext cx="5143500" cy="308610"/>
+          </a:xfrm>
+          <a:prstGeom prst="rect">
+            <a:avLst/>
+          </a:prstGeom>
+          <a:noFill/>
+        </p:spPr>
+        <p:txBody>
+          <a:bodyPr wrap="square" lIns="27432" rIns="27432" tIns="13716" bIns="13716" anchor="t">
+            <a:spAutoFit/>
+          </a:bodyPr>
+          <a:lstStyle/>
+          <a:p>
+            <a:pPr algn="l"/>
+            <a:r>
+              <a:rPr sz="1125" b="0" i="0">
+                <a:solidFill>
+                  <a:srgbClr val="1F2937"/>
+                </a:solidFill>
+                <a:latin typeface="Calibri"/>
+              </a:rPr>
+              <a:t>兩邊交錯進行 —— 看到 teal 提示列就切到 Colab</a:t>
+            </a:r>
+          </a:p>
+        </p:txBody>
+      </p:sp>
+      <p:sp>
+        <p:nvSpPr>
+          <p:cNvPr id="10" name="TextBox 9"/>
+          <p:cNvSpPr txBox="1"/>
+          <p:nvPr/>
+        </p:nvSpPr>
+        <p:spPr>
+          <a:xfrm>
+            <a:off x="582930" y="4320540"/>
+            <a:ext cx="5486400" cy="274320"/>
+          </a:xfrm>
+          <a:prstGeom prst="rect">
+            <a:avLst/>
+          </a:prstGeom>
+          <a:noFill/>
+        </p:spPr>
+        <p:txBody>
+          <a:bodyPr wrap="square" lIns="27432" rIns="27432" tIns="13716" bIns="13716" anchor="t">
+            <a:spAutoFit/>
+          </a:bodyPr>
+          <a:lstStyle/>
+          <a:p>
+            <a:pPr algn="l"/>
+            <a:r>
+              <a:rPr sz="1350" b="1" i="0">
+                <a:solidFill>
+                  <a:srgbClr val="1F2937"/>
+                </a:solidFill>
+                <a:latin typeface="Calibri"/>
+              </a:rPr>
+              <a:t>范耀中  Yao-Chung Fan</a:t>
+            </a:r>
+          </a:p>
+        </p:txBody>
+      </p:sp>
+      <p:sp>
+        <p:nvSpPr>
+          <p:cNvPr id="11" name="TextBox 10"/>
+          <p:cNvSpPr txBox="1"/>
+          <p:nvPr/>
+        </p:nvSpPr>
+        <p:spPr>
+          <a:xfrm>
+            <a:off x="582930" y="4629150"/>
+            <a:ext cx="5486400" cy="274320"/>
+          </a:xfrm>
+          <a:prstGeom prst="rect">
+            <a:avLst/>
+          </a:prstGeom>
+          <a:noFill/>
+        </p:spPr>
+        <p:txBody>
+          <a:bodyPr wrap="square" lIns="27432" rIns="27432" tIns="13716" bIns="13716" anchor="t">
+            <a:spAutoFit/>
+          </a:bodyPr>
+          <a:lstStyle/>
+          <a:p>
+            <a:pPr algn="l"/>
+            <a:r>
+              <a:rPr sz="1050" b="0" i="0">
                 <a:solidFill>
                   <a:srgbClr val="9CA3AF"/>
                 </a:solidFill>
                 <a:latin typeface="Calibri"/>
               </a:rPr>
-              <a:t>在你自己的瀏覽器,把一個 AI 能力從「無」變到「有」</a:t>
-            </a:r>
-          </a:p>
-        </p:txBody>
-      </p:sp>
-      <p:sp>
-        <p:nvSpPr>
-          <p:cNvPr id="7" name="TextBox 6"/>
-          <p:cNvSpPr txBox="1"/>
-          <p:nvPr/>
-        </p:nvSpPr>
-        <p:spPr>
-          <a:xfrm>
-            <a:off x="651509" y="3188970"/>
-            <a:ext cx="7818120" cy="685800"/>
-          </a:xfrm>
-          <a:prstGeom prst="rect">
-            <a:avLst/>
-          </a:prstGeom>
-          <a:noFill/>
-        </p:spPr>
-        <p:txBody>
-          <a:bodyPr wrap="square" lIns="27432" rIns="27432" tIns="13716" bIns="13716" anchor="t">
-            <a:spAutoFit/>
-          </a:bodyPr>
-          <a:lstStyle/>
-          <a:p>
-            <a:pPr algn="l"/>
-            <a:r>
-              <a:rPr sz="1275" b="0" i="0">
-                <a:solidFill>
-                  <a:srgbClr val="7B5CF5"/>
-                </a:solidFill>
-                <a:latin typeface="Calibri"/>
-              </a:rPr>
-              <a:t>給工具 → 換你的資料 → 自己選工具填參數 → 接外部 API → 撐大資料 → 親手造一支</a:t>
-            </a:r>
-          </a:p>
-        </p:txBody>
-      </p:sp>
-      <p:sp>
-        <p:nvSpPr>
-          <p:cNvPr id="8" name="TextBox 7"/>
-          <p:cNvSpPr txBox="1"/>
-          <p:nvPr/>
-        </p:nvSpPr>
-        <p:spPr>
-          <a:xfrm>
-            <a:off x="651509" y="4423410"/>
-            <a:ext cx="7543800" cy="342900"/>
-          </a:xfrm>
-          <a:prstGeom prst="rect">
-            <a:avLst/>
-          </a:prstGeom>
-          <a:noFill/>
-        </p:spPr>
-        <p:txBody>
-          <a:bodyPr wrap="square" lIns="27432" rIns="27432" tIns="13716" bIns="13716" anchor="t">
-            <a:spAutoFit/>
-          </a:bodyPr>
-          <a:lstStyle/>
-          <a:p>
-            <a:pPr algn="l"/>
-            <a:r>
-              <a:rPr sz="1050" b="0" i="0">
-                <a:solidFill>
-                  <a:srgbClr val="9CA3AF"/>
-                </a:solidFill>
-                <a:latin typeface="Calibri"/>
-              </a:rPr>
-              <a:t>本投影片講概念,實作在 Colab 現場做 —— 兩邊交錯進行。</a:t>
+              <a:t>國立中興大學  ·  AI 學伴系統實務案例</a:t>
             </a:r>
           </a:p>
         </p:txBody>
@@ -4114,7 +4232,7 @@
             <a:avLst/>
           </a:prstGeom>
           <a:solidFill>
-            <a:srgbClr val="0F1429"/>
+            <a:srgbClr val="FFFFFF"/>
           </a:solidFill>
           <a:ln>
             <a:noFill/>
@@ -4144,14 +4262,93 @@
       </p:sp>
       <p:sp>
         <p:nvSpPr>
-          <p:cNvPr id="3" name="TextBox 2"/>
-          <p:cNvSpPr txBox="1"/>
-          <p:nvPr/>
-        </p:nvSpPr>
-        <p:spPr>
-          <a:xfrm>
-            <a:off x="617220" y="514350"/>
-            <a:ext cx="7543800" cy="342900"/>
+          <p:cNvPr id="3" name="Oval 2"/>
+          <p:cNvSpPr/>
+          <p:nvPr/>
+        </p:nvSpPr>
+        <p:spPr>
+          <a:xfrm>
+            <a:off x="445769" y="240030"/>
+            <a:ext cx="274320" cy="274320"/>
+          </a:xfrm>
+          <a:prstGeom prst="ellipse">
+            <a:avLst/>
+          </a:prstGeom>
+          <a:solidFill>
+            <a:srgbClr val="7B5CF5"/>
+          </a:solidFill>
+          <a:ln>
+            <a:noFill/>
+          </a:ln>
+          <a:effectLst/>
+        </p:spPr>
+        <p:style>
+          <a:lnRef idx="1">
+            <a:schemeClr val="accent1"/>
+          </a:lnRef>
+          <a:fillRef idx="3">
+            <a:schemeClr val="accent1"/>
+          </a:fillRef>
+          <a:effectRef idx="2">
+            <a:schemeClr val="accent1"/>
+          </a:effectRef>
+          <a:fontRef idx="minor">
+            <a:schemeClr val="lt1"/>
+          </a:fontRef>
+        </p:style>
+        <p:txBody>
+          <a:bodyPr rtlCol="0" anchor="ctr"/>
+          <a:lstStyle/>
+          <a:p>
+            <a:pPr algn="ctr"/>
+          </a:p>
+        </p:txBody>
+      </p:sp>
+      <p:sp>
+        <p:nvSpPr>
+          <p:cNvPr id="4" name="TextBox 3"/>
+          <p:cNvSpPr txBox="1"/>
+          <p:nvPr/>
+        </p:nvSpPr>
+        <p:spPr>
+          <a:xfrm>
+            <a:off x="822959" y="205739"/>
+            <a:ext cx="8229600" cy="377190"/>
+          </a:xfrm>
+          <a:prstGeom prst="rect">
+            <a:avLst/>
+          </a:prstGeom>
+          <a:noFill/>
+        </p:spPr>
+        <p:txBody>
+          <a:bodyPr wrap="square" lIns="27432" rIns="27432" tIns="13716" bIns="13716" anchor="ctr">
+            <a:spAutoFit/>
+          </a:bodyPr>
+          <a:lstStyle/>
+          <a:p>
+            <a:pPr algn="l"/>
+            <a:r>
+              <a:rPr sz="1125" b="1" i="0">
+                <a:solidFill>
+                  <a:srgbClr val="9CA3AF"/>
+                </a:solidFill>
+                <a:latin typeface="Calibri"/>
+              </a:rPr>
+              <a:t>收尾   W R A P   U P</a:t>
+            </a:r>
+          </a:p>
+        </p:txBody>
+      </p:sp>
+      <p:sp>
+        <p:nvSpPr>
+          <p:cNvPr id="5" name="TextBox 4"/>
+          <p:cNvSpPr txBox="1"/>
+          <p:nvPr/>
+        </p:nvSpPr>
+        <p:spPr>
+          <a:xfrm>
+            <a:off x="582930" y="651509"/>
+            <a:ext cx="8229600" cy="651509"/>
           </a:xfrm>
           <a:prstGeom prst="rect">
             <a:avLst/>
@@ -4166,27 +4363,27 @@
           <a:p>
             <a:pPr algn="l"/>
             <a:r>
-              <a:rPr sz="1125" b="1" i="0">
-                <a:solidFill>
-                  <a:srgbClr val="9CA3AF"/>
-                </a:solidFill>
-                <a:latin typeface="Calibri"/>
-              </a:rPr>
-              <a:t>W R A P   U P</a:t>
-            </a:r>
-          </a:p>
-        </p:txBody>
-      </p:sp>
-      <p:sp>
-        <p:nvSpPr>
-          <p:cNvPr id="4" name="TextBox 3"/>
-          <p:cNvSpPr txBox="1"/>
-          <p:nvPr/>
-        </p:nvSpPr>
-        <p:spPr>
-          <a:xfrm>
-            <a:off x="582930" y="1028700"/>
-            <a:ext cx="7955279" cy="617220"/>
+              <a:rPr sz="3150" b="1" i="0">
+                <a:solidFill>
+                  <a:srgbClr val="1F2937"/>
+                </a:solidFill>
+                <a:latin typeface="Arial Black"/>
+              </a:rPr>
+              <a:t>你剛剛走完的旅程</a:t>
+            </a:r>
+          </a:p>
+        </p:txBody>
+      </p:sp>
+      <p:sp>
+        <p:nvSpPr>
+          <p:cNvPr id="6" name="TextBox 5"/>
+          <p:cNvSpPr txBox="1"/>
+          <p:nvPr/>
+        </p:nvSpPr>
+        <p:spPr>
+          <a:xfrm>
+            <a:off x="582930" y="1268730"/>
+            <a:ext cx="8229600" cy="377190"/>
           </a:xfrm>
           <a:prstGeom prst="rect">
             <a:avLst/>
@@ -4201,27 +4398,110 @@
           <a:p>
             <a:pPr algn="l"/>
             <a:r>
-              <a:rPr sz="3000" b="1" i="0">
-                <a:solidFill>
-                  <a:srgbClr val="FFFFFF"/>
+              <a:rPr sz="1275" b="0" i="1">
+                <a:solidFill>
+                  <a:srgbClr val="6B7280"/>
+                </a:solidFill>
+                <a:latin typeface="Calibri"/>
+              </a:rPr>
+              <a:t>從「給一支工具」到「親手造一支」—— 六步,一個能力從無到有</a:t>
+            </a:r>
+          </a:p>
+        </p:txBody>
+      </p:sp>
+      <p:sp>
+        <p:nvSpPr>
+          <p:cNvPr id="7" name="Rounded Rectangle 6"/>
+          <p:cNvSpPr/>
+          <p:nvPr/>
+        </p:nvSpPr>
+        <p:spPr>
+          <a:xfrm>
+            <a:off x="582930" y="1748789"/>
+            <a:ext cx="2640330" cy="2331720"/>
+          </a:xfrm>
+          <a:prstGeom prst="roundRect">
+            <a:avLst>
+              <a:gd name="adj" fmla="val 10000"/>
+            </a:avLst>
+          </a:prstGeom>
+          <a:solidFill>
+            <a:srgbClr val="EEE8FF"/>
+          </a:solidFill>
+          <a:ln w="19050">
+            <a:solidFill>
+              <a:srgbClr val="7B5CF5"/>
+            </a:solidFill>
+          </a:ln>
+          <a:effectLst/>
+        </p:spPr>
+        <p:style>
+          <a:lnRef idx="1">
+            <a:schemeClr val="accent1"/>
+          </a:lnRef>
+          <a:fillRef idx="3">
+            <a:schemeClr val="accent1"/>
+          </a:fillRef>
+          <a:effectRef idx="2">
+            <a:schemeClr val="accent1"/>
+          </a:effectRef>
+          <a:fontRef idx="minor">
+            <a:schemeClr val="lt1"/>
+          </a:fontRef>
+        </p:style>
+        <p:txBody>
+          <a:bodyPr rtlCol="0" anchor="ctr"/>
+          <a:lstStyle/>
+          <a:p>
+            <a:pPr algn="ctr"/>
+          </a:p>
+        </p:txBody>
+      </p:sp>
+      <p:sp>
+        <p:nvSpPr>
+          <p:cNvPr id="8" name="TextBox 7"/>
+          <p:cNvSpPr txBox="1"/>
+          <p:nvPr/>
+        </p:nvSpPr>
+        <p:spPr>
+          <a:xfrm>
+            <a:off x="754380" y="1872234"/>
+            <a:ext cx="2297430" cy="377190"/>
+          </a:xfrm>
+          <a:prstGeom prst="rect">
+            <a:avLst/>
+          </a:prstGeom>
+          <a:noFill/>
+        </p:spPr>
+        <p:txBody>
+          <a:bodyPr wrap="square" lIns="27432" rIns="27432" tIns="13716" bIns="13716" anchor="t">
+            <a:spAutoFit/>
+          </a:bodyPr>
+          <a:lstStyle/>
+          <a:p>
+            <a:pPr algn="l"/>
+            <a:r>
+              <a:rPr sz="1350" b="1" i="0">
+                <a:solidFill>
+                  <a:srgbClr val="7B5CF5"/>
                 </a:solidFill>
                 <a:latin typeface="Arial Black"/>
               </a:rPr>
-              <a:t>你剛剛走完的旅程</a:t>
-            </a:r>
-          </a:p>
-        </p:txBody>
-      </p:sp>
-      <p:sp>
-        <p:nvSpPr>
-          <p:cNvPr id="5" name="TextBox 4"/>
-          <p:cNvSpPr txBox="1"/>
-          <p:nvPr/>
-        </p:nvSpPr>
-        <p:spPr>
-          <a:xfrm>
-            <a:off x="822959" y="1851660"/>
-            <a:ext cx="7543800" cy="2263139"/>
+              <a:t>1–2 · 連上你的世界</a:t>
+            </a:r>
+          </a:p>
+        </p:txBody>
+      </p:sp>
+      <p:sp>
+        <p:nvSpPr>
+          <p:cNvPr id="9" name="TextBox 8"/>
+          <p:cNvSpPr txBox="1"/>
+          <p:nvPr/>
+        </p:nvSpPr>
+        <p:spPr>
+          <a:xfrm>
+            <a:off x="774953" y="2400300"/>
+            <a:ext cx="2297430" cy="1508760"/>
           </a:xfrm>
           <a:prstGeom prst="rect">
             <a:avLst/>
@@ -4236,111 +4516,265 @@
           <a:p>
             <a:pPr algn="l">
               <a:spcAft>
-                <a:spcPts val="675"/>
+                <a:spcPts val="600"/>
               </a:spcAft>
             </a:pPr>
             <a:r>
-              <a:rPr sz="1350" b="0" i="0">
-                <a:solidFill>
-                  <a:srgbClr val="FFFFFF"/>
-                </a:solidFill>
-                <a:latin typeface="Calibri"/>
-              </a:rPr>
-              <a:t>1 · 給 LLM 工具,看見它連上世界（看得見的 loop）</a:t>
+              <a:rPr sz="1087" b="0" i="0">
+                <a:solidFill>
+                  <a:srgbClr val="374151"/>
+                </a:solidFill>
+                <a:latin typeface="Calibri"/>
+              </a:rPr>
+              <a:t>看見 loop 在背後跑</a:t>
             </a:r>
           </a:p>
           <a:p>
             <a:pPr algn="l">
               <a:spcAft>
-                <a:spcPts val="675"/>
+                <a:spcPts val="600"/>
               </a:spcAft>
             </a:pPr>
             <a:r>
-              <a:rPr sz="1350" b="0" i="0">
-                <a:solidFill>
-                  <a:srgbClr val="FFFFFF"/>
-                </a:solidFill>
-                <a:latin typeface="Calibri"/>
-              </a:rPr>
-              <a:t>2 · 換成你的資料,零邏輯改動（L1）</a:t>
+              <a:rPr sz="1087" b="0" i="0">
+                <a:solidFill>
+                  <a:srgbClr val="374151"/>
+                </a:solidFill>
+                <a:latin typeface="Calibri"/>
+              </a:rPr>
+              <a:t>把它換成你的資料</a:t>
             </a:r>
           </a:p>
           <a:p>
             <a:pPr algn="l">
               <a:spcAft>
-                <a:spcPts val="675"/>
+                <a:spcPts val="600"/>
               </a:spcAft>
             </a:pPr>
             <a:r>
-              <a:rPr sz="1350" b="0" i="0">
-                <a:solidFill>
-                  <a:srgbClr val="FFFFFF"/>
-                </a:solidFill>
-                <a:latin typeface="Calibri"/>
-              </a:rPr>
-              <a:t>3 · 讓它自己選工具、填參數（L2）</a:t>
-            </a:r>
-          </a:p>
+              <a:rPr sz="1087" b="0" i="0">
+                <a:solidFill>
+                  <a:srgbClr val="374151"/>
+                </a:solidFill>
+                <a:latin typeface="Calibri"/>
+              </a:rPr>
+              <a:t>（零邏輯改動,L1）</a:t>
+            </a:r>
+          </a:p>
+        </p:txBody>
+      </p:sp>
+      <p:sp>
+        <p:nvSpPr>
+          <p:cNvPr id="10" name="Rounded Rectangle 9"/>
+          <p:cNvSpPr/>
+          <p:nvPr/>
+        </p:nvSpPr>
+        <p:spPr>
+          <a:xfrm>
+            <a:off x="3360420" y="1748789"/>
+            <a:ext cx="2640330" cy="2331720"/>
+          </a:xfrm>
+          <a:prstGeom prst="roundRect">
+            <a:avLst>
+              <a:gd name="adj" fmla="val 10000"/>
+            </a:avLst>
+          </a:prstGeom>
+          <a:solidFill>
+            <a:srgbClr val="FFE7DB"/>
+          </a:solidFill>
+          <a:ln w="19050">
+            <a:solidFill>
+              <a:srgbClr val="FB7048"/>
+            </a:solidFill>
+          </a:ln>
+          <a:effectLst/>
+        </p:spPr>
+        <p:style>
+          <a:lnRef idx="1">
+            <a:schemeClr val="accent1"/>
+          </a:lnRef>
+          <a:fillRef idx="3">
+            <a:schemeClr val="accent1"/>
+          </a:fillRef>
+          <a:effectRef idx="2">
+            <a:schemeClr val="accent1"/>
+          </a:effectRef>
+          <a:fontRef idx="minor">
+            <a:schemeClr val="lt1"/>
+          </a:fontRef>
+        </p:style>
+        <p:txBody>
+          <a:bodyPr rtlCol="0" anchor="ctr"/>
+          <a:lstStyle/>
+          <a:p>
+            <a:pPr algn="ctr"/>
+          </a:p>
+        </p:txBody>
+      </p:sp>
+      <p:sp>
+        <p:nvSpPr>
+          <p:cNvPr id="11" name="TextBox 10"/>
+          <p:cNvSpPr txBox="1"/>
+          <p:nvPr/>
+        </p:nvSpPr>
+        <p:spPr>
+          <a:xfrm>
+            <a:off x="3531870" y="1872234"/>
+            <a:ext cx="2297430" cy="377190"/>
+          </a:xfrm>
+          <a:prstGeom prst="rect">
+            <a:avLst/>
+          </a:prstGeom>
+          <a:noFill/>
+        </p:spPr>
+        <p:txBody>
+          <a:bodyPr wrap="square" lIns="27432" rIns="27432" tIns="13716" bIns="13716" anchor="t">
+            <a:spAutoFit/>
+          </a:bodyPr>
+          <a:lstStyle/>
+          <a:p>
+            <a:pPr algn="l"/>
+            <a:r>
+              <a:rPr sz="1350" b="1" i="0">
+                <a:solidFill>
+                  <a:srgbClr val="FB7048"/>
+                </a:solidFill>
+                <a:latin typeface="Arial Black"/>
+              </a:rPr>
+              <a:t>3–5 · 更真實的工具</a:t>
+            </a:r>
+          </a:p>
+        </p:txBody>
+      </p:sp>
+      <p:sp>
+        <p:nvSpPr>
+          <p:cNvPr id="12" name="TextBox 11"/>
+          <p:cNvSpPr txBox="1"/>
+          <p:nvPr/>
+        </p:nvSpPr>
+        <p:spPr>
+          <a:xfrm>
+            <a:off x="3552444" y="2400300"/>
+            <a:ext cx="2297430" cy="1508760"/>
+          </a:xfrm>
+          <a:prstGeom prst="rect">
+            <a:avLst/>
+          </a:prstGeom>
+          <a:noFill/>
+        </p:spPr>
+        <p:txBody>
+          <a:bodyPr wrap="square" lIns="27432" rIns="27432" tIns="13716" bIns="13716" anchor="t">
+            <a:spAutoFit/>
+          </a:bodyPr>
+          <a:lstStyle/>
           <a:p>
             <a:pPr algn="l">
               <a:spcAft>
-                <a:spcPts val="675"/>
+                <a:spcPts val="600"/>
               </a:spcAft>
             </a:pPr>
             <a:r>
-              <a:rPr sz="1350" b="0" i="0">
-                <a:solidFill>
-                  <a:srgbClr val="FFFFFF"/>
-                </a:solidFill>
-                <a:latin typeface="Calibri"/>
-              </a:rPr>
-              <a:t>4 · 接真實外部 API（L3）</a:t>
+              <a:rPr sz="1087" b="0" i="0">
+                <a:solidFill>
+                  <a:srgbClr val="374151"/>
+                </a:solidFill>
+                <a:latin typeface="Calibri"/>
+              </a:rPr>
+              <a:t>LLM 自己選工具填參數</a:t>
             </a:r>
           </a:p>
           <a:p>
             <a:pPr algn="l">
               <a:spcAft>
-                <a:spcPts val="675"/>
+                <a:spcPts val="600"/>
               </a:spcAft>
             </a:pPr>
             <a:r>
-              <a:rPr sz="1350" b="0" i="0">
-                <a:solidFill>
-                  <a:srgbClr val="FFFFFF"/>
-                </a:solidFill>
-                <a:latin typeface="Calibri"/>
-              </a:rPr>
-              <a:t>5 · 撐住 3018 筆大資料（L4）</a:t>
+              <a:rPr sz="1087" b="0" i="0">
+                <a:solidFill>
+                  <a:srgbClr val="374151"/>
+                </a:solidFill>
+                <a:latin typeface="Calibri"/>
+              </a:rPr>
+              <a:t>接真實外部 API</a:t>
             </a:r>
           </a:p>
           <a:p>
             <a:pPr algn="l">
               <a:spcAft>
-                <a:spcPts val="675"/>
+                <a:spcPts val="600"/>
               </a:spcAft>
             </a:pPr>
             <a:r>
-              <a:rPr sz="1350" b="0" i="0">
-                <a:solidFill>
-                  <a:srgbClr val="FFFFFF"/>
-                </a:solidFill>
-                <a:latin typeface="Calibri"/>
-              </a:rPr>
-              <a:t>6 · 親手造一支新工具,給 LLM 新能力（L5）</a:t>
-            </a:r>
-          </a:p>
-        </p:txBody>
-      </p:sp>
-      <p:sp>
-        <p:nvSpPr>
-          <p:cNvPr id="6" name="TextBox 5"/>
-          <p:cNvSpPr txBox="1"/>
-          <p:nvPr/>
-        </p:nvSpPr>
-        <p:spPr>
-          <a:xfrm>
-            <a:off x="651509" y="4354829"/>
-            <a:ext cx="7818120" cy="480059"/>
+              <a:rPr sz="1087" b="0" i="0">
+                <a:solidFill>
+                  <a:srgbClr val="374151"/>
+                </a:solidFill>
+                <a:latin typeface="Calibri"/>
+              </a:rPr>
+              <a:t>撐住 3018 筆大資料</a:t>
+            </a:r>
+          </a:p>
+        </p:txBody>
+      </p:sp>
+      <p:sp>
+        <p:nvSpPr>
+          <p:cNvPr id="13" name="Rounded Rectangle 12"/>
+          <p:cNvSpPr/>
+          <p:nvPr/>
+        </p:nvSpPr>
+        <p:spPr>
+          <a:xfrm>
+            <a:off x="6137909" y="1748789"/>
+            <a:ext cx="2640330" cy="2331720"/>
+          </a:xfrm>
+          <a:prstGeom prst="roundRect">
+            <a:avLst>
+              <a:gd name="adj" fmla="val 10000"/>
+            </a:avLst>
+          </a:prstGeom>
+          <a:solidFill>
+            <a:srgbClr val="D4F7F0"/>
+          </a:solidFill>
+          <a:ln w="19050">
+            <a:solidFill>
+              <a:srgbClr val="0EA594"/>
+            </a:solidFill>
+          </a:ln>
+          <a:effectLst/>
+        </p:spPr>
+        <p:style>
+          <a:lnRef idx="1">
+            <a:schemeClr val="accent1"/>
+          </a:lnRef>
+          <a:fillRef idx="3">
+            <a:schemeClr val="accent1"/>
+          </a:fillRef>
+          <a:effectRef idx="2">
+            <a:schemeClr val="accent1"/>
+          </a:effectRef>
+          <a:fontRef idx="minor">
+            <a:schemeClr val="lt1"/>
+          </a:fontRef>
+        </p:style>
+        <p:txBody>
+          <a:bodyPr rtlCol="0" anchor="ctr"/>
+          <a:lstStyle/>
+          <a:p>
+            <a:pPr algn="ctr"/>
+          </a:p>
+        </p:txBody>
+      </p:sp>
+      <p:sp>
+        <p:nvSpPr>
+          <p:cNvPr id="14" name="TextBox 13"/>
+          <p:cNvSpPr txBox="1"/>
+          <p:nvPr/>
+        </p:nvSpPr>
+        <p:spPr>
+          <a:xfrm>
+            <a:off x="6309359" y="1872234"/>
+            <a:ext cx="2297430" cy="377190"/>
           </a:xfrm>
           <a:prstGeom prst="rect">
             <a:avLst/>
@@ -4355,13 +4789,202 @@
           <a:p>
             <a:pPr algn="l"/>
             <a:r>
-              <a:rPr sz="1125" b="0" i="0">
+              <a:rPr sz="1350" b="1" i="0">
+                <a:solidFill>
+                  <a:srgbClr val="0EA594"/>
+                </a:solidFill>
+                <a:latin typeface="Arial Black"/>
+              </a:rPr>
+              <a:t>6 · 親手造一支</a:t>
+            </a:r>
+          </a:p>
+        </p:txBody>
+      </p:sp>
+      <p:sp>
+        <p:nvSpPr>
+          <p:cNvPr id="15" name="TextBox 14"/>
+          <p:cNvSpPr txBox="1"/>
+          <p:nvPr/>
+        </p:nvSpPr>
+        <p:spPr>
+          <a:xfrm>
+            <a:off x="6329933" y="2400300"/>
+            <a:ext cx="2297430" cy="1508760"/>
+          </a:xfrm>
+          <a:prstGeom prst="rect">
+            <a:avLst/>
+          </a:prstGeom>
+          <a:noFill/>
+        </p:spPr>
+        <p:txBody>
+          <a:bodyPr wrap="square" lIns="27432" rIns="27432" tIns="13716" bIns="13716" anchor="t">
+            <a:spAutoFit/>
+          </a:bodyPr>
+          <a:lstStyle/>
+          <a:p>
+            <a:pPr algn="l">
+              <a:spcAft>
+                <a:spcPts val="600"/>
+              </a:spcAft>
+            </a:pPr>
+            <a:r>
+              <a:rPr sz="1087" b="0" i="0">
+                <a:solidFill>
+                  <a:srgbClr val="374151"/>
+                </a:solidFill>
+                <a:latin typeface="Calibri"/>
+              </a:rPr>
+              <a:t>寫一支 LLM 辦不到的工具</a:t>
+            </a:r>
+          </a:p>
+          <a:p>
+            <a:pPr algn="l">
+              <a:spcAft>
+                <a:spcPts val="600"/>
+              </a:spcAft>
+            </a:pPr>
+            <a:r>
+              <a:rPr sz="1087" b="0" i="0">
+                <a:solidFill>
+                  <a:srgbClr val="374151"/>
+                </a:solidFill>
+                <a:latin typeface="Calibri"/>
+              </a:rPr>
+              <a:t>→ 它有了新能力</a:t>
+            </a:r>
+          </a:p>
+          <a:p>
+            <a:pPr algn="l">
+              <a:spcAft>
+                <a:spcPts val="600"/>
+              </a:spcAft>
+            </a:pPr>
+            <a:r>
+              <a:rPr sz="1087" b="0" i="0">
+                <a:solidFill>
+                  <a:srgbClr val="374151"/>
+                </a:solidFill>
+                <a:latin typeface="Calibri"/>
+              </a:rPr>
+              <a:t>這 = MCP 的全部意義</a:t>
+            </a:r>
+          </a:p>
+        </p:txBody>
+      </p:sp>
+      <p:sp>
+        <p:nvSpPr>
+          <p:cNvPr id="16" name="Rounded Rectangle 15"/>
+          <p:cNvSpPr/>
+          <p:nvPr/>
+        </p:nvSpPr>
+        <p:spPr>
+          <a:xfrm>
+            <a:off x="582930" y="4457700"/>
+            <a:ext cx="8229600" cy="411479"/>
+          </a:xfrm>
+          <a:prstGeom prst="roundRect">
+            <a:avLst>
+              <a:gd name="adj" fmla="val 10000"/>
+            </a:avLst>
+          </a:prstGeom>
+          <a:solidFill>
+            <a:srgbClr val="EEE8FF"/>
+          </a:solidFill>
+          <a:ln w="19050">
+            <a:solidFill>
+              <a:srgbClr val="7B5CF5"/>
+            </a:solidFill>
+          </a:ln>
+          <a:effectLst/>
+        </p:spPr>
+        <p:style>
+          <a:lnRef idx="1">
+            <a:schemeClr val="accent1"/>
+          </a:lnRef>
+          <a:fillRef idx="3">
+            <a:schemeClr val="accent1"/>
+          </a:fillRef>
+          <a:effectRef idx="2">
+            <a:schemeClr val="accent1"/>
+          </a:effectRef>
+          <a:fontRef idx="minor">
+            <a:schemeClr val="lt1"/>
+          </a:fontRef>
+        </p:style>
+        <p:txBody>
+          <a:bodyPr rtlCol="0" anchor="ctr"/>
+          <a:lstStyle/>
+          <a:p>
+            <a:pPr algn="ctr"/>
+          </a:p>
+        </p:txBody>
+      </p:sp>
+      <p:sp>
+        <p:nvSpPr>
+          <p:cNvPr id="17" name="TextBox 16"/>
+          <p:cNvSpPr txBox="1"/>
+          <p:nvPr/>
+        </p:nvSpPr>
+        <p:spPr>
+          <a:xfrm>
+            <a:off x="788669" y="4457700"/>
+            <a:ext cx="7818120" cy="411479"/>
+          </a:xfrm>
+          <a:prstGeom prst="rect">
+            <a:avLst/>
+          </a:prstGeom>
+          <a:noFill/>
+        </p:spPr>
+        <p:txBody>
+          <a:bodyPr wrap="square" lIns="27432" rIns="27432" tIns="13716" bIns="13716" anchor="ctr">
+            <a:spAutoFit/>
+          </a:bodyPr>
+          <a:lstStyle/>
+          <a:p>
+            <a:pPr algn="l"/>
+            <a:r>
+              <a:rPr sz="1050" b="1" i="0">
                 <a:solidFill>
                   <a:srgbClr val="7B5CF5"/>
                 </a:solidFill>
                 <a:latin typeface="Calibri"/>
               </a:rPr>
-              <a:t>接下來 Segment 5：3 支工具 → 239 支工具,真實上線會遇到的 scale / 品質 / 成本。</a:t>
+              <a:t>▶  從 3 支工具 到 239 支 —— Segment 5：真實上線的 scale / 品質 / 模型選擇 / 成本</a:t>
+            </a:r>
+          </a:p>
+        </p:txBody>
+      </p:sp>
+      <p:sp>
+        <p:nvSpPr>
+          <p:cNvPr id="18" name="TextBox 17"/>
+          <p:cNvSpPr txBox="1"/>
+          <p:nvPr/>
+        </p:nvSpPr>
+        <p:spPr>
+          <a:xfrm>
+            <a:off x="7955279" y="4766310"/>
+            <a:ext cx="1028700" cy="240029"/>
+          </a:xfrm>
+          <a:prstGeom prst="rect">
+            <a:avLst/>
+          </a:prstGeom>
+          <a:noFill/>
+        </p:spPr>
+        <p:txBody>
+          <a:bodyPr wrap="square" lIns="27432" rIns="27432" tIns="13716" bIns="13716" anchor="t">
+            <a:spAutoFit/>
+          </a:bodyPr>
+          <a:lstStyle/>
+          <a:p>
+            <a:pPr algn="r"/>
+            <a:r>
+              <a:rPr sz="1050" b="0" i="0">
+                <a:solidFill>
+                  <a:srgbClr val="9CA3AF"/>
+                </a:solidFill>
+                <a:latin typeface="Calibri"/>
+              </a:rPr>
+              <a:t>11 / 13</a:t>
             </a:r>
           </a:p>
         </p:txBody>

</xml_diff>

<commit_message>
feat(seg4-slides): 步驟頁加真實程式碼/軌跡 artifact(改善點 2)
hands-on 段原本只「講」程式碼、從不「show」。在三個最具體的時刻放真實 artifact:
- 第1步:加「看得見的 loop」server-log tool_use 軌跡(學員在 Colab 會親眼看到的那串)
- 第2步(L1):「改 docstring」從文字卡換成真實 docstring 程式碼片段
- 第6步(L5):放學員親手寫的 get_today() 真實程式碼(@mcp.tool + datetime)
用既有 dark code_block,概念頁就跟 Colab 實際畫面接起來。
另:清掉 slide 上的 emoji(🔑🔍🚀✏️🔄☰ 在 LibreOffice 會變豆腐),
cue 改以 cell 名稱引導;✓✗→▶ 維持(可正常 render)。
</commit_message>
<xml_diff>
--- a/slides/04-hands-on-lab.pptx
+++ b/slides/04-hands-on-lab.pptx
@@ -3685,7 +3685,7 @@
                 </a:solidFill>
                 <a:latin typeface="Calibri"/>
               </a:rPr>
-              <a:t>給 LLM 一個它本來絕對辦不到的能力 —— 整趟旅程的高潮</a:t>
+              <a:t>給 LLM 一個它本來辦不到的能力 —— 旅程的高潮</a:t>
             </a:r>
           </a:p>
         </p:txBody>
@@ -3698,8 +3698,8 @@
         </p:nvSpPr>
         <p:spPr>
           <a:xfrm>
-            <a:off x="582930" y="1714500"/>
-            <a:ext cx="3771900" cy="1851660"/>
+            <a:off x="582930" y="1680210"/>
+            <a:ext cx="2880360" cy="2400300"/>
           </a:xfrm>
           <a:prstGeom prst="roundRect">
             <a:avLst>
@@ -3746,8 +3746,8 @@
         </p:nvSpPr>
         <p:spPr>
           <a:xfrm>
-            <a:off x="754380" y="1837944"/>
-            <a:ext cx="3429000" cy="377190"/>
+            <a:off x="754380" y="1803654"/>
+            <a:ext cx="2537460" cy="377190"/>
           </a:xfrm>
           <a:prstGeom prst="rect">
             <a:avLst/>
@@ -3762,13 +3762,13 @@
           <a:p>
             <a:pPr algn="l"/>
             <a:r>
-              <a:rPr sz="1575" b="1" i="0">
+              <a:rPr sz="1350" b="1" i="0">
                 <a:solidFill>
                   <a:srgbClr val="EF4444"/>
                 </a:solidFill>
                 <a:latin typeface="Arial Black"/>
               </a:rPr>
-              <a:t>① 先問（它辦不到）</a:t>
+              <a:t>① 先問,它辦不到</a:t>
             </a:r>
           </a:p>
         </p:txBody>
@@ -3781,8 +3781,8 @@
         </p:nvSpPr>
         <p:spPr>
           <a:xfrm>
-            <a:off x="788669" y="2366010"/>
-            <a:ext cx="3429000" cy="1028700"/>
+            <a:off x="788669" y="2194560"/>
+            <a:ext cx="2537460" cy="1783080"/>
           </a:xfrm>
           <a:prstGeom prst="rect">
             <a:avLst/>
@@ -3801,7 +3801,7 @@
               </a:spcAft>
             </a:pPr>
             <a:r>
-              <a:rPr sz="1162" b="0" i="0">
+              <a:rPr sz="1050" b="0" i="0">
                 <a:solidFill>
                   <a:srgbClr val="374151"/>
                 </a:solidFill>
@@ -3813,60 +3813,87 @@
           <a:p>
             <a:pPr algn="l">
               <a:spcAft>
-                <a:spcPts val="600"/>
+                <a:spcPts val="375"/>
               </a:spcAft>
             </a:pPr>
             <a:r>
-              <a:rPr sz="1162" b="0" i="0">
+              <a:rPr sz="1012" b="0" i="0">
                 <a:solidFill>
                   <a:srgbClr val="374151"/>
                 </a:solidFill>
                 <a:latin typeface="Calibri"/>
               </a:rPr>
-              <a:t>✗ LLM 沒有「現在」的概念</a:t>
-            </a:r>
-          </a:p>
-          <a:p>
-            <a:pPr algn="l">
-              <a:spcAft>
-                <a:spcPts val="600"/>
-              </a:spcAft>
-            </a:pPr>
-            <a:r>
-              <a:rPr sz="1162" b="0" i="0">
+              <a:t>✗ LLM 沒有「現在」概念</a:t>
+            </a:r>
+          </a:p>
+          <a:p>
+            <a:pPr algn="l"/>
+            <a:r>
+              <a:rPr sz="1012" b="0" i="0">
                 <a:solidFill>
                   <a:srgbClr val="374151"/>
                 </a:solidFill>
                 <a:latin typeface="Calibri"/>
               </a:rPr>
-              <a:t>✗ 沒有時鐘 → 說不知道或亂猜</a:t>
-            </a:r>
-          </a:p>
-        </p:txBody>
-      </p:sp>
-      <p:sp>
-        <p:nvSpPr>
-          <p:cNvPr id="10" name="Rounded Rectangle 9"/>
+              <a:t>✗ 沒時鐘 → 亂猜或說不知道</a:t>
+            </a:r>
+          </a:p>
+        </p:txBody>
+      </p:sp>
+      <p:sp>
+        <p:nvSpPr>
+          <p:cNvPr id="10" name="TextBox 9"/>
+          <p:cNvSpPr txBox="1"/>
+          <p:nvPr/>
+        </p:nvSpPr>
+        <p:spPr>
+          <a:xfrm>
+            <a:off x="3669029" y="1680210"/>
+            <a:ext cx="4869179" cy="274320"/>
+          </a:xfrm>
+          <a:prstGeom prst="rect">
+            <a:avLst/>
+          </a:prstGeom>
+          <a:noFill/>
+        </p:spPr>
+        <p:txBody>
+          <a:bodyPr wrap="square" lIns="27432" rIns="27432" tIns="13716" bIns="13716" anchor="t">
+            <a:spAutoFit/>
+          </a:bodyPr>
+          <a:lstStyle/>
+          <a:p>
+            <a:pPr algn="l"/>
+            <a:r>
+              <a:rPr sz="1012" b="1" i="0">
+                <a:solidFill>
+                  <a:srgbClr val="0F766E"/>
+                </a:solidFill>
+                <a:latin typeface="Calibri"/>
+              </a:rPr>
+              <a:t>② 你親手寫這幾行 → 它就有了新能力</a:t>
+            </a:r>
+          </a:p>
+        </p:txBody>
+      </p:sp>
+      <p:sp>
+        <p:nvSpPr>
+          <p:cNvPr id="11" name="Rectangle 10"/>
           <p:cNvSpPr/>
           <p:nvPr/>
         </p:nvSpPr>
         <p:spPr>
           <a:xfrm>
-            <a:off x="4766310" y="1714500"/>
-            <a:ext cx="3771900" cy="1851660"/>
-          </a:xfrm>
-          <a:prstGeom prst="roundRect">
-            <a:avLst>
-              <a:gd name="adj" fmla="val 10000"/>
-            </a:avLst>
+            <a:off x="3669029" y="2023110"/>
+            <a:ext cx="4869179" cy="2057400"/>
+          </a:xfrm>
+          <a:prstGeom prst="rect">
+            <a:avLst/>
           </a:prstGeom>
           <a:solidFill>
-            <a:srgbClr val="D4F7F0"/>
+            <a:srgbClr val="1A2138"/>
           </a:solidFill>
-          <a:ln w="19050">
-            <a:solidFill>
-              <a:srgbClr val="0EA594"/>
-            </a:solidFill>
+          <a:ln>
+            <a:noFill/>
           </a:ln>
           <a:effectLst/>
         </p:spPr>
@@ -3894,49 +3921,14 @@
       </p:sp>
       <p:sp>
         <p:nvSpPr>
-          <p:cNvPr id="11" name="TextBox 10"/>
-          <p:cNvSpPr txBox="1"/>
-          <p:nvPr/>
-        </p:nvSpPr>
-        <p:spPr>
-          <a:xfrm>
-            <a:off x="4937760" y="1837944"/>
-            <a:ext cx="3429000" cy="377190"/>
-          </a:xfrm>
-          <a:prstGeom prst="rect">
-            <a:avLst/>
-          </a:prstGeom>
-          <a:noFill/>
-        </p:spPr>
-        <p:txBody>
-          <a:bodyPr wrap="square" lIns="27432" rIns="27432" tIns="13716" bIns="13716" anchor="t">
-            <a:spAutoFit/>
-          </a:bodyPr>
-          <a:lstStyle/>
-          <a:p>
-            <a:pPr algn="l"/>
-            <a:r>
-              <a:rPr sz="1575" b="1" i="0">
-                <a:solidFill>
-                  <a:srgbClr val="0EA594"/>
-                </a:solidFill>
-                <a:latin typeface="Arial Black"/>
-              </a:rPr>
-              <a:t>② 造工具 → 再問</a:t>
-            </a:r>
-          </a:p>
-        </p:txBody>
-      </p:sp>
-      <p:sp>
-        <p:nvSpPr>
           <p:cNvPr id="12" name="TextBox 11"/>
           <p:cNvSpPr txBox="1"/>
           <p:nvPr/>
         </p:nvSpPr>
         <p:spPr>
           <a:xfrm>
-            <a:off x="4972050" y="2366010"/>
-            <a:ext cx="3429000" cy="1028700"/>
+            <a:off x="3888485" y="2173986"/>
+            <a:ext cx="4491990" cy="1769364"/>
           </a:xfrm>
           <a:prstGeom prst="rect">
             <a:avLst/>
@@ -3951,49 +3943,129 @@
           <a:p>
             <a:pPr algn="l">
               <a:spcAft>
-                <a:spcPts val="600"/>
+                <a:spcPts val="75"/>
               </a:spcAft>
             </a:pPr>
             <a:r>
-              <a:rPr sz="1162" b="0" i="0">
-                <a:solidFill>
-                  <a:srgbClr val="374151"/>
-                </a:solidFill>
-                <a:latin typeface="Calibri"/>
-              </a:rPr>
-              <a:t>寫一支 get_today()（用 datetime）</a:t>
+              <a:rPr sz="937" b="0" i="0">
+                <a:solidFill>
+                  <a:srgbClr val="FB924D"/>
+                </a:solidFill>
+                <a:latin typeface="Consolas"/>
+              </a:rPr>
+              <a:t>@mcp.tool()</a:t>
             </a:r>
           </a:p>
           <a:p>
             <a:pPr algn="l">
               <a:spcAft>
-                <a:spcPts val="600"/>
+                <a:spcPts val="75"/>
               </a:spcAft>
             </a:pPr>
             <a:r>
-              <a:rPr sz="1162" b="0" i="0">
-                <a:solidFill>
-                  <a:srgbClr val="374151"/>
-                </a:solidFill>
-                <a:latin typeface="Calibri"/>
-              </a:rPr>
-              <a:t>✓ 重啟後再問 → 它答對了</a:t>
+              <a:rPr sz="937" b="0" i="0">
+                <a:solidFill>
+                  <a:srgbClr val="E5E7EB"/>
+                </a:solidFill>
+                <a:latin typeface="Consolas"/>
+              </a:rPr>
+              <a:t>def get_today() -&gt; str:</a:t>
             </a:r>
           </a:p>
           <a:p>
             <a:pPr algn="l">
               <a:spcAft>
-                <a:spcPts val="600"/>
+                <a:spcPts val="75"/>
               </a:spcAft>
             </a:pPr>
             <a:r>
-              <a:rPr sz="1162" b="0" i="0">
-                <a:solidFill>
-                  <a:srgbClr val="374151"/>
-                </a:solidFill>
-                <a:latin typeface="Calibri"/>
-              </a:rPr>
-              <a:t>✓ 你剛給了 AI 一個新能力</a:t>
+              <a:rPr sz="937" b="0" i="0">
+                <a:solidFill>
+                  <a:srgbClr val="A8E1B4"/>
+                </a:solidFill>
+                <a:latin typeface="Consolas"/>
+              </a:rPr>
+              <a:t>    """回傳今天日期與星期幾。</a:t>
+            </a:r>
+          </a:p>
+          <a:p>
+            <a:pPr algn="l">
+              <a:spcAft>
+                <a:spcPts val="75"/>
+              </a:spcAft>
+            </a:pPr>
+            <a:r>
+              <a:rPr sz="937" b="0" i="0">
+                <a:solidFill>
+                  <a:srgbClr val="A8E1B4"/>
+                </a:solidFill>
+                <a:latin typeface="Consolas"/>
+              </a:rPr>
+              <a:t>    使用情境:問今天幾號/星期幾時呼叫。"""</a:t>
+            </a:r>
+          </a:p>
+          <a:p>
+            <a:pPr algn="l">
+              <a:spcAft>
+                <a:spcPts val="75"/>
+              </a:spcAft>
+            </a:pPr>
+            <a:r>
+              <a:rPr sz="937" b="0" i="0">
+                <a:solidFill>
+                  <a:srgbClr val="E5E7EB"/>
+                </a:solidFill>
+                <a:latin typeface="Consolas"/>
+              </a:rPr>
+              <a:t>    t = datetime.date.today()</a:t>
+            </a:r>
+          </a:p>
+          <a:p>
+            <a:pPr algn="l">
+              <a:spcAft>
+                <a:spcPts val="75"/>
+              </a:spcAft>
+            </a:pPr>
+            <a:r>
+              <a:rPr sz="937" b="0" i="0">
+                <a:solidFill>
+                  <a:srgbClr val="E5E7EB"/>
+                </a:solidFill>
+                <a:latin typeface="Consolas"/>
+              </a:rPr>
+              <a:t>    wd = "一二三四五六日"[t.weekday()]</a:t>
+            </a:r>
+          </a:p>
+          <a:p>
+            <a:pPr algn="l">
+              <a:spcAft>
+                <a:spcPts val="75"/>
+              </a:spcAft>
+            </a:pPr>
+            <a:r>
+              <a:rPr sz="937" b="0" i="0">
+                <a:solidFill>
+                  <a:srgbClr val="E5E7EB"/>
+                </a:solidFill>
+                <a:latin typeface="Consolas"/>
+              </a:rPr>
+              <a:t>    return json.dumps(</a:t>
+            </a:r>
+          </a:p>
+          <a:p>
+            <a:pPr algn="l">
+              <a:spcAft>
+                <a:spcPts val="75"/>
+              </a:spcAft>
+            </a:pPr>
+            <a:r>
+              <a:rPr sz="937" b="0" i="0">
+                <a:solidFill>
+                  <a:srgbClr val="E5E7EB"/>
+                </a:solidFill>
+                <a:latin typeface="Consolas"/>
+              </a:rPr>
+              <a:t>        {"今天": t.isoformat(), "星期": wd})</a:t>
             </a:r>
           </a:p>
         </p:txBody>
@@ -4001,89 +4073,6 @@
       <p:sp>
         <p:nvSpPr>
           <p:cNvPr id="13" name="Rounded Rectangle 12"/>
-          <p:cNvSpPr/>
-          <p:nvPr/>
-        </p:nvSpPr>
-        <p:spPr>
-          <a:xfrm>
-            <a:off x="582930" y="3737610"/>
-            <a:ext cx="8229600" cy="377190"/>
-          </a:xfrm>
-          <a:prstGeom prst="roundRect">
-            <a:avLst>
-              <a:gd name="adj" fmla="val 10000"/>
-            </a:avLst>
-          </a:prstGeom>
-          <a:solidFill>
-            <a:srgbClr val="FFE7DB"/>
-          </a:solidFill>
-          <a:ln w="19050">
-            <a:solidFill>
-              <a:srgbClr val="FB7048"/>
-            </a:solidFill>
-          </a:ln>
-          <a:effectLst/>
-        </p:spPr>
-        <p:style>
-          <a:lnRef idx="1">
-            <a:schemeClr val="accent1"/>
-          </a:lnRef>
-          <a:fillRef idx="3">
-            <a:schemeClr val="accent1"/>
-          </a:fillRef>
-          <a:effectRef idx="2">
-            <a:schemeClr val="accent1"/>
-          </a:effectRef>
-          <a:fontRef idx="minor">
-            <a:schemeClr val="lt1"/>
-          </a:fontRef>
-        </p:style>
-        <p:txBody>
-          <a:bodyPr rtlCol="0" anchor="ctr"/>
-          <a:lstStyle/>
-          <a:p>
-            <a:pPr algn="ctr"/>
-          </a:p>
-        </p:txBody>
-      </p:sp>
-      <p:sp>
-        <p:nvSpPr>
-          <p:cNvPr id="14" name="TextBox 13"/>
-          <p:cNvSpPr txBox="1"/>
-          <p:nvPr/>
-        </p:nvSpPr>
-        <p:spPr>
-          <a:xfrm>
-            <a:off x="788669" y="3737610"/>
-            <a:ext cx="7818120" cy="377190"/>
-          </a:xfrm>
-          <a:prstGeom prst="rect">
-            <a:avLst/>
-          </a:prstGeom>
-          <a:noFill/>
-        </p:spPr>
-        <p:txBody>
-          <a:bodyPr wrap="square" lIns="27432" rIns="27432" tIns="13716" bIns="13716" anchor="ctr">
-            <a:spAutoFit/>
-          </a:bodyPr>
-          <a:lstStyle/>
-          <a:p>
-            <a:pPr algn="l"/>
-            <a:r>
-              <a:rPr sz="1050" b="1" i="0">
-                <a:solidFill>
-                  <a:srgbClr val="FB7048"/>
-                </a:solidFill>
-                <a:latin typeface="Calibri"/>
-              </a:rPr>
-              <a:t>▶  這 = MCP 的全部意義。Segment 1 問「怎麼讓 LLM 連上真實世界」,答案就是你剛做的這件事</a:t>
-            </a:r>
-          </a:p>
-        </p:txBody>
-      </p:sp>
-      <p:sp>
-        <p:nvSpPr>
-          <p:cNvPr id="15" name="Rounded Rectangle 14"/>
           <p:cNvSpPr/>
           <p:nvPr/>
         </p:nvSpPr>
@@ -4131,7 +4120,7 @@
       </p:sp>
       <p:sp>
         <p:nvSpPr>
-          <p:cNvPr id="16" name="TextBox 15"/>
+          <p:cNvPr id="14" name="TextBox 13"/>
           <p:cNvSpPr txBox="1"/>
           <p:nvPr/>
         </p:nvSpPr>
@@ -4159,14 +4148,14 @@
                 </a:solidFill>
                 <a:latin typeface="Calibri"/>
               </a:rPr>
-              <a:t>▶  切到 Colab　— 第 6 步：L5 ①先問失敗 → ②寫 today_tool → ③再問答對</a:t>
-            </a:r>
-          </a:p>
-        </p:txBody>
-      </p:sp>
-      <p:sp>
-        <p:nvSpPr>
-          <p:cNvPr id="17" name="TextBox 16"/>
+              <a:t>▶  切到 Colab　— 第 6 步：「先問失敗」→「造 today_tool」→ 再問答對 = MCP 的全部意義</a:t>
+            </a:r>
+          </a:p>
+        </p:txBody>
+      </p:sp>
+      <p:sp>
+        <p:nvSpPr>
+          <p:cNvPr id="15" name="TextBox 14"/>
           <p:cNvSpPr txBox="1"/>
           <p:nvPr/>
         </p:nvSpPr>
@@ -6023,7 +6012,7 @@
                 </a:solidFill>
                 <a:latin typeface="Calibri"/>
               </a:rPr>
-              <a:t>→ 確認以 sk-ant- 開頭;或用 Colab 🔑 Secrets 設 ANTHROPIC_API_KEY</a:t>
+              <a:t>→ 確認以 sk-ant- 開頭;或用 Colab Secrets 設 ANTHROPIC_API_KEY</a:t>
             </a:r>
           </a:p>
         </p:txBody>
@@ -7924,7 +7913,7 @@
                 </a:solidFill>
                 <a:latin typeface="Calibri"/>
               </a:rPr>
-              <a:t>• 左側 ☰ 目錄當投影片導覽</a:t>
+              <a:t>• 左側 目錄當投影片導覽</a:t>
             </a:r>
           </a:p>
           <a:p>
@@ -8415,7 +8404,7 @@
                 </a:solidFill>
                 <a:latin typeface="Consolas"/>
               </a:rPr>
-              <a:t>   — Colab 左側 🔑 Secrets 設一次,或當場貼上</a:t>
+              <a:t>   — Colab 左側 Secrets 設一次,或當場貼上</a:t>
             </a:r>
           </a:p>
         </p:txBody>
@@ -8743,7 +8732,7 @@
                 </a:solidFill>
                 <a:latin typeface="Calibri"/>
               </a:rPr>
-              <a:t>LLM 很會講話,但摸不到外部世界 —— 工具就是那座橋</a:t>
+              <a:t>工具就是那座橋 —— 而且你看得見它在背後呼叫</a:t>
             </a:r>
           </a:p>
         </p:txBody>
@@ -8756,8 +8745,8 @@
         </p:nvSpPr>
         <p:spPr>
           <a:xfrm>
-            <a:off x="582930" y="1714500"/>
-            <a:ext cx="3771900" cy="2057400"/>
+            <a:off x="582930" y="1645919"/>
+            <a:ext cx="3771900" cy="1062990"/>
           </a:xfrm>
           <a:prstGeom prst="roundRect">
             <a:avLst>
@@ -8804,7 +8793,7 @@
         </p:nvSpPr>
         <p:spPr>
           <a:xfrm>
-            <a:off x="754380" y="1837944"/>
+            <a:off x="754380" y="1769364"/>
             <a:ext cx="3429000" cy="377190"/>
           </a:xfrm>
           <a:prstGeom prst="rect">
@@ -8820,7 +8809,7 @@
           <a:p>
             <a:pPr algn="l"/>
             <a:r>
-              <a:rPr sz="1575" b="1" i="0">
+              <a:rPr sz="1350" b="1" i="0">
                 <a:solidFill>
                   <a:srgbClr val="EF4444"/>
                 </a:solidFill>
@@ -8839,8 +8828,8 @@
         </p:nvSpPr>
         <p:spPr>
           <a:xfrm>
-            <a:off x="788669" y="2366010"/>
-            <a:ext cx="3429000" cy="1234440"/>
+            <a:off x="788669" y="2112264"/>
+            <a:ext cx="3429000" cy="548640"/>
           </a:xfrm>
           <a:prstGeom prst="rect">
             <a:avLst/>
@@ -8855,59 +8844,23 @@
           <a:p>
             <a:pPr algn="l">
               <a:spcAft>
-                <a:spcPts val="600"/>
+                <a:spcPts val="225"/>
               </a:spcAft>
             </a:pPr>
             <a:r>
-              <a:rPr sz="1162" b="0" i="0">
+              <a:rPr sz="1012" b="0" i="0">
                 <a:solidFill>
                   <a:srgbClr val="374151"/>
                 </a:solidFill>
                 <a:latin typeface="Calibri"/>
               </a:rPr>
-              <a:t>✗ 不知道今天幾號</a:t>
-            </a:r>
-          </a:p>
-          <a:p>
-            <a:pPr algn="l">
-              <a:spcAft>
-                <a:spcPts val="600"/>
-              </a:spcAft>
-            </a:pPr>
-            <a:r>
-              <a:rPr sz="1162" b="0" i="0">
-                <a:solidFill>
-                  <a:srgbClr val="374151"/>
-                </a:solidFill>
-                <a:latin typeface="Calibri"/>
-              </a:rPr>
-              <a:t>✗ 查不到圖書館有沒有某本書</a:t>
-            </a:r>
-          </a:p>
-          <a:p>
-            <a:pPr algn="l">
-              <a:spcAft>
-                <a:spcPts val="600"/>
-              </a:spcAft>
-            </a:pPr>
-            <a:r>
-              <a:rPr sz="1162" b="0" i="0">
-                <a:solidFill>
-                  <a:srgbClr val="374151"/>
-                </a:solidFill>
-                <a:latin typeface="Calibri"/>
-              </a:rPr>
-              <a:t>✗ 看不到你研究室的資料</a:t>
-            </a:r>
-          </a:p>
-          <a:p>
-            <a:pPr algn="l">
-              <a:spcAft>
-                <a:spcPts val="600"/>
-              </a:spcAft>
-            </a:pPr>
-            <a:r>
-              <a:rPr sz="1162" b="0" i="0">
+              <a:t>✗ 不知道今天幾號、查不到館藏</a:t>
+            </a:r>
+          </a:p>
+          <a:p>
+            <a:pPr algn="l"/>
+            <a:r>
+              <a:rPr sz="1012" b="0" i="0">
                 <a:solidFill>
                   <a:srgbClr val="374151"/>
                 </a:solidFill>
@@ -8926,8 +8879,8 @@
         </p:nvSpPr>
         <p:spPr>
           <a:xfrm>
-            <a:off x="4766310" y="1714500"/>
-            <a:ext cx="3771900" cy="2057400"/>
+            <a:off x="4766310" y="1645919"/>
+            <a:ext cx="3771900" cy="1062990"/>
           </a:xfrm>
           <a:prstGeom prst="roundRect">
             <a:avLst>
@@ -8974,7 +8927,7 @@
         </p:nvSpPr>
         <p:spPr>
           <a:xfrm>
-            <a:off x="4937760" y="1837944"/>
+            <a:off x="4937760" y="1769364"/>
             <a:ext cx="3429000" cy="377190"/>
           </a:xfrm>
           <a:prstGeom prst="rect">
@@ -8990,7 +8943,7 @@
           <a:p>
             <a:pPr algn="l"/>
             <a:r>
-              <a:rPr sz="1575" b="1" i="0">
+              <a:rPr sz="1350" b="1" i="0">
                 <a:solidFill>
                   <a:srgbClr val="0EA594"/>
                 </a:solidFill>
@@ -9009,8 +8962,8 @@
         </p:nvSpPr>
         <p:spPr>
           <a:xfrm>
-            <a:off x="4972050" y="2366010"/>
-            <a:ext cx="3429000" cy="1234440"/>
+            <a:off x="4972050" y="2112264"/>
+            <a:ext cx="3429000" cy="548640"/>
           </a:xfrm>
           <a:prstGeom prst="rect">
             <a:avLst/>
@@ -9025,72 +8978,202 @@
           <a:p>
             <a:pPr algn="l">
               <a:spcAft>
-                <a:spcPts val="600"/>
+                <a:spcPts val="225"/>
               </a:spcAft>
             </a:pPr>
             <a:r>
-              <a:rPr sz="1162" b="0" i="0">
+              <a:rPr sz="1012" b="0" i="0">
                 <a:solidFill>
                   <a:srgbClr val="374151"/>
                 </a:solidFill>
                 <a:latin typeface="Calibri"/>
               </a:rPr>
-              <a:t>✓ 自己決定呼叫哪支工具</a:t>
-            </a:r>
-          </a:p>
+              <a:t>✓ 自己呼叫工具、拿真實資料再答</a:t>
+            </a:r>
+          </a:p>
+          <a:p>
+            <a:pPr algn="l"/>
+            <a:r>
+              <a:rPr sz="1012" b="0" i="0">
+                <a:solidFill>
+                  <a:srgbClr val="374151"/>
+                </a:solidFill>
+                <a:latin typeface="Calibri"/>
+              </a:rPr>
+              <a:t>→ 這就是 agentic loop</a:t>
+            </a:r>
+          </a:p>
+        </p:txBody>
+      </p:sp>
+      <p:sp>
+        <p:nvSpPr>
+          <p:cNvPr id="13" name="TextBox 12"/>
+          <p:cNvSpPr txBox="1"/>
+          <p:nvPr/>
+        </p:nvSpPr>
+        <p:spPr>
+          <a:xfrm>
+            <a:off x="582930" y="2846070"/>
+            <a:ext cx="8229600" cy="240029"/>
+          </a:xfrm>
+          <a:prstGeom prst="rect">
+            <a:avLst/>
+          </a:prstGeom>
+          <a:noFill/>
+        </p:spPr>
+        <p:txBody>
+          <a:bodyPr wrap="square" lIns="27432" rIns="27432" tIns="13716" bIns="13716" anchor="t">
+            <a:spAutoFit/>
+          </a:bodyPr>
+          <a:lstStyle/>
+          <a:p>
+            <a:pPr algn="l"/>
+            <a:r>
+              <a:rPr sz="975" b="0" i="0">
+                <a:solidFill>
+                  <a:srgbClr val="9CA3AF"/>
+                </a:solidFill>
+                <a:latin typeface="Calibri"/>
+              </a:rPr>
+              <a:t>在 Colab「看得見的 loop」那格,你會親眼看到這串：</a:t>
+            </a:r>
+          </a:p>
+        </p:txBody>
+      </p:sp>
+      <p:sp>
+        <p:nvSpPr>
+          <p:cNvPr id="14" name="Rectangle 13"/>
+          <p:cNvSpPr/>
+          <p:nvPr/>
+        </p:nvSpPr>
+        <p:spPr>
+          <a:xfrm>
+            <a:off x="582930" y="3120389"/>
+            <a:ext cx="8229600" cy="1028700"/>
+          </a:xfrm>
+          <a:prstGeom prst="rect">
+            <a:avLst/>
+          </a:prstGeom>
+          <a:solidFill>
+            <a:srgbClr val="1A2138"/>
+          </a:solidFill>
+          <a:ln>
+            <a:noFill/>
+          </a:ln>
+          <a:effectLst/>
+        </p:spPr>
+        <p:style>
+          <a:lnRef idx="1">
+            <a:schemeClr val="accent1"/>
+          </a:lnRef>
+          <a:fillRef idx="3">
+            <a:schemeClr val="accent1"/>
+          </a:fillRef>
+          <a:effectRef idx="2">
+            <a:schemeClr val="accent1"/>
+          </a:effectRef>
+          <a:fontRef idx="minor">
+            <a:schemeClr val="lt1"/>
+          </a:fontRef>
+        </p:style>
+        <p:txBody>
+          <a:bodyPr rtlCol="0" anchor="ctr"/>
+          <a:lstStyle/>
+          <a:p>
+            <a:pPr algn="ctr"/>
+          </a:p>
+        </p:txBody>
+      </p:sp>
+      <p:sp>
+        <p:nvSpPr>
+          <p:cNvPr id="15" name="TextBox 14"/>
+          <p:cNvSpPr txBox="1"/>
+          <p:nvPr/>
+        </p:nvSpPr>
+        <p:spPr>
+          <a:xfrm>
+            <a:off x="802386" y="3271265"/>
+            <a:ext cx="7852409" cy="740664"/>
+          </a:xfrm>
+          <a:prstGeom prst="rect">
+            <a:avLst/>
+          </a:prstGeom>
+          <a:noFill/>
+        </p:spPr>
+        <p:txBody>
+          <a:bodyPr wrap="square" lIns="27432" rIns="27432" tIns="13716" bIns="13716" anchor="t">
+            <a:spAutoFit/>
+          </a:bodyPr>
+          <a:lstStyle/>
           <a:p>
             <a:pPr algn="l">
               <a:spcAft>
-                <a:spcPts val="600"/>
+                <a:spcPts val="75"/>
               </a:spcAft>
             </a:pPr>
             <a:r>
-              <a:rPr sz="1162" b="0" i="0">
-                <a:solidFill>
-                  <a:srgbClr val="374151"/>
-                </a:solidFill>
-                <a:latin typeface="Calibri"/>
-              </a:rPr>
-              <a:t>✓ 拿到真實資料再回答</a:t>
+              <a:rPr sz="975" b="0" i="0">
+                <a:solidFill>
+                  <a:srgbClr val="9CA3AF"/>
+                </a:solidFill>
+                <a:latin typeface="Consolas"/>
+              </a:rPr>
+              <a:t># 你問:「資工系深度學習的課,老師有什麼論文?」</a:t>
             </a:r>
           </a:p>
           <a:p>
             <a:pPr algn="l">
               <a:spcAft>
-                <a:spcPts val="600"/>
+                <a:spcPts val="75"/>
               </a:spcAft>
             </a:pPr>
             <a:r>
-              <a:rPr sz="1162" b="0" i="0">
-                <a:solidFill>
-                  <a:srgbClr val="374151"/>
-                </a:solidFill>
-                <a:latin typeface="Calibri"/>
-              </a:rPr>
-              <a:t>✓ 你還「看得見」它在背後呼叫</a:t>
+              <a:rPr sz="975" b="0" i="0">
+                <a:solidFill>
+                  <a:srgbClr val="E5E7EB"/>
+                </a:solidFill>
+                <a:latin typeface="Consolas"/>
+              </a:rPr>
+              <a:t>[tool_use] search_courses</a:t>
             </a:r>
           </a:p>
           <a:p>
             <a:pPr algn="l">
               <a:spcAft>
-                <a:spcPts val="600"/>
+                <a:spcPts val="75"/>
               </a:spcAft>
             </a:pPr>
             <a:r>
-              <a:rPr sz="1162" b="0" i="0">
-                <a:solidFill>
-                  <a:srgbClr val="374151"/>
-                </a:solidFill>
-                <a:latin typeface="Calibri"/>
-              </a:rPr>
-              <a:t>→ 這就是 agentic loop</a:t>
-            </a:r>
-          </a:p>
-        </p:txBody>
-      </p:sp>
-      <p:sp>
-        <p:nvSpPr>
-          <p:cNvPr id="13" name="Rounded Rectangle 12"/>
+              <a:rPr sz="975" b="0" i="0">
+                <a:solidFill>
+                  <a:srgbClr val="E5E7EB"/>
+                </a:solidFill>
+                <a:latin typeface="Consolas"/>
+              </a:rPr>
+              <a:t>[tool_use] search_arxiv</a:t>
+            </a:r>
+          </a:p>
+          <a:p>
+            <a:pPr algn="l">
+              <a:spcAft>
+                <a:spcPts val="75"/>
+              </a:spcAft>
+            </a:pPr>
+            <a:r>
+              <a:rPr sz="975" b="0" i="0">
+                <a:solidFill>
+                  <a:srgbClr val="9CA3AF"/>
+                </a:solidFill>
+                <a:latin typeface="Consolas"/>
+              </a:rPr>
+              <a:t>(stop_reason: end_turn  →  LLM 整合成一段回覆)</a:t>
+            </a:r>
+          </a:p>
+        </p:txBody>
+      </p:sp>
+      <p:sp>
+        <p:nvSpPr>
+          <p:cNvPr id="16" name="Rounded Rectangle 15"/>
           <p:cNvSpPr/>
           <p:nvPr/>
         </p:nvSpPr>
@@ -9138,7 +9221,7 @@
       </p:sp>
       <p:sp>
         <p:nvSpPr>
-          <p:cNvPr id="14" name="TextBox 13"/>
+          <p:cNvPr id="17" name="TextBox 16"/>
           <p:cNvSpPr txBox="1"/>
           <p:nvPr/>
         </p:nvSpPr>
@@ -9166,14 +9249,14 @@
                 </a:solidFill>
                 <a:latin typeface="Calibri"/>
               </a:rPr>
-              <a:t>▶  切到 Colab　— 第 1 步：啟動 server → 問一題 → 跑「看得見的 loop」那格</a:t>
-            </a:r>
-          </a:p>
-        </p:txBody>
-      </p:sp>
-      <p:sp>
-        <p:nvSpPr>
-          <p:cNvPr id="15" name="TextBox 14"/>
+              <a:t>▶  切到 Colab　— 第 1 步：跑「啟動 server」→ 問一題 →「看得見的 loop」</a:t>
+            </a:r>
+          </a:p>
+        </p:txBody>
+      </p:sp>
+      <p:sp>
+        <p:nvSpPr>
+          <p:cNvPr id="18" name="TextBox 17"/>
           <p:cNvSpPr txBox="1"/>
           <p:nvPr/>
         </p:nvSpPr>
@@ -9411,7 +9494,7 @@
                 </a:solidFill>
                 <a:latin typeface="Calibri"/>
               </a:rPr>
-              <a:t>不寫一行新邏輯,只動兩樣東西</a:t>
+              <a:t>不寫一行新邏輯,只動兩樣：換資料 + 改說明書</a:t>
             </a:r>
           </a:p>
         </p:txBody>
@@ -9424,8 +9507,8 @@
         </p:nvSpPr>
         <p:spPr>
           <a:xfrm>
-            <a:off x="582930" y="1714500"/>
-            <a:ext cx="3771900" cy="1851660"/>
+            <a:off x="582930" y="1680210"/>
+            <a:ext cx="2880360" cy="2400300"/>
           </a:xfrm>
           <a:prstGeom prst="roundRect">
             <a:avLst>
@@ -9472,8 +9555,8 @@
         </p:nvSpPr>
         <p:spPr>
           <a:xfrm>
-            <a:off x="754380" y="1837944"/>
-            <a:ext cx="3429000" cy="377190"/>
+            <a:off x="754380" y="1803654"/>
+            <a:ext cx="2537460" cy="377190"/>
           </a:xfrm>
           <a:prstGeom prst="rect">
             <a:avLst/>
@@ -9488,7 +9571,7 @@
           <a:p>
             <a:pPr algn="l"/>
             <a:r>
-              <a:rPr sz="1575" b="1" i="0">
+              <a:rPr sz="1425" b="1" i="0">
                 <a:solidFill>
                   <a:srgbClr val="FB7048"/>
                 </a:solidFill>
@@ -9507,8 +9590,8 @@
         </p:nvSpPr>
         <p:spPr>
           <a:xfrm>
-            <a:off x="788669" y="2366010"/>
-            <a:ext cx="3429000" cy="1028700"/>
+            <a:off x="788669" y="2194560"/>
+            <a:ext cx="2537460" cy="1783080"/>
           </a:xfrm>
           <a:prstGeom prst="rect">
             <a:avLst/>
@@ -9523,92 +9606,135 @@
           <a:p>
             <a:pPr algn="l">
               <a:spcAft>
-                <a:spcPts val="600"/>
+                <a:spcPts val="375"/>
               </a:spcAft>
             </a:pPr>
             <a:r>
-              <a:rPr sz="1162" b="0" i="0">
+              <a:rPr sz="1050" b="0" i="0">
                 <a:solidFill>
                   <a:srgbClr val="374151"/>
                 </a:solidFill>
                 <a:latin typeface="Calibri"/>
               </a:rPr>
-              <a:t>把英文中心的 JSON</a:t>
+              <a:t>把 data/ 裡的 JSON</a:t>
             </a:r>
           </a:p>
           <a:p>
             <a:pPr algn="l">
               <a:spcAft>
-                <a:spcPts val="600"/>
+                <a:spcPts val="375"/>
               </a:spcAft>
             </a:pPr>
             <a:r>
-              <a:rPr sz="1162" b="0" i="0">
+              <a:rPr sz="1050" b="0" i="0">
                 <a:solidFill>
                   <a:srgbClr val="374151"/>
                 </a:solidFill>
                 <a:latin typeface="Calibri"/>
               </a:rPr>
-              <a:t>換成你的：實驗室 / 課程 /</a:t>
+              <a:t>換成你的領域：</a:t>
             </a:r>
           </a:p>
           <a:p>
             <a:pPr algn="l">
               <a:spcAft>
-                <a:spcPts val="600"/>
+                <a:spcPts val="375"/>
               </a:spcAft>
             </a:pPr>
             <a:r>
-              <a:rPr sz="1162" b="0" i="0">
+              <a:rPr sz="1050" b="0" i="0">
                 <a:solidFill>
                   <a:srgbClr val="374151"/>
                 </a:solidFill>
                 <a:latin typeface="Calibri"/>
               </a:rPr>
-              <a:t>研究成果 …任何你想被</a:t>
+              <a:t>實驗室 / 課程 /</a:t>
             </a:r>
           </a:p>
           <a:p>
             <a:pPr algn="l">
               <a:spcAft>
-                <a:spcPts val="600"/>
+                <a:spcPts val="900"/>
               </a:spcAft>
             </a:pPr>
             <a:r>
-              <a:rPr sz="1162" b="0" i="0">
+              <a:rPr sz="1050" b="0" i="0">
                 <a:solidFill>
                   <a:srgbClr val="374151"/>
                 </a:solidFill>
                 <a:latin typeface="Calibri"/>
               </a:rPr>
-              <a:t>自然語言問的資料</a:t>
-            </a:r>
-          </a:p>
-        </p:txBody>
-      </p:sp>
-      <p:sp>
-        <p:nvSpPr>
-          <p:cNvPr id="10" name="Rounded Rectangle 9"/>
+              <a:t>研究成果 …</a:t>
+            </a:r>
+          </a:p>
+          <a:p>
+            <a:pPr algn="l"/>
+            <a:r>
+              <a:rPr sz="975" b="0" i="0">
+                <a:solidFill>
+                  <a:srgbClr val="9CA3AF"/>
+                </a:solidFill>
+                <a:latin typeface="Calibri"/>
+              </a:rPr>
+              <a:t>（0 行 Python）</a:t>
+            </a:r>
+          </a:p>
+        </p:txBody>
+      </p:sp>
+      <p:sp>
+        <p:nvSpPr>
+          <p:cNvPr id="10" name="TextBox 9"/>
+          <p:cNvSpPr txBox="1"/>
+          <p:nvPr/>
+        </p:nvSpPr>
+        <p:spPr>
+          <a:xfrm>
+            <a:off x="3669029" y="1680210"/>
+            <a:ext cx="4869179" cy="274320"/>
+          </a:xfrm>
+          <a:prstGeom prst="rect">
+            <a:avLst/>
+          </a:prstGeom>
+          <a:noFill/>
+        </p:spPr>
+        <p:txBody>
+          <a:bodyPr wrap="square" lIns="27432" rIns="27432" tIns="13716" bIns="13716" anchor="t">
+            <a:spAutoFit/>
+          </a:bodyPr>
+          <a:lstStyle/>
+          <a:p>
+            <a:pPr algn="l"/>
+            <a:r>
+              <a:rPr sz="975" b="1" i="0">
+                <a:solidFill>
+                  <a:srgbClr val="5B3ED9"/>
+                </a:solidFill>
+                <a:latin typeface="Calibri"/>
+              </a:rPr>
+              <a:t>② 改說明書 docstring —— LLM 靠這段決定何時呼叫這支工具</a:t>
+            </a:r>
+          </a:p>
+        </p:txBody>
+      </p:sp>
+      <p:sp>
+        <p:nvSpPr>
+          <p:cNvPr id="11" name="Rectangle 10"/>
           <p:cNvSpPr/>
           <p:nvPr/>
         </p:nvSpPr>
         <p:spPr>
           <a:xfrm>
-            <a:off x="4766310" y="1714500"/>
-            <a:ext cx="3771900" cy="1851660"/>
-          </a:xfrm>
-          <a:prstGeom prst="roundRect">
-            <a:avLst>
-              <a:gd name="adj" fmla="val 10000"/>
-            </a:avLst>
+            <a:off x="3669029" y="2023110"/>
+            <a:ext cx="4869179" cy="2057400"/>
+          </a:xfrm>
+          <a:prstGeom prst="rect">
+            <a:avLst/>
           </a:prstGeom>
           <a:solidFill>
-            <a:srgbClr val="EEE8FF"/>
+            <a:srgbClr val="1A2138"/>
           </a:solidFill>
-          <a:ln w="19050">
-            <a:solidFill>
-              <a:srgbClr val="7B5CF5"/>
-            </a:solidFill>
+          <a:ln>
+            <a:noFill/>
           </a:ln>
           <a:effectLst/>
         </p:spPr>
@@ -9636,49 +9762,14 @@
       </p:sp>
       <p:sp>
         <p:nvSpPr>
-          <p:cNvPr id="11" name="TextBox 10"/>
-          <p:cNvSpPr txBox="1"/>
-          <p:nvPr/>
-        </p:nvSpPr>
-        <p:spPr>
-          <a:xfrm>
-            <a:off x="4937760" y="1837944"/>
-            <a:ext cx="3429000" cy="377190"/>
-          </a:xfrm>
-          <a:prstGeom prst="rect">
-            <a:avLst/>
-          </a:prstGeom>
-          <a:noFill/>
-        </p:spPr>
-        <p:txBody>
-          <a:bodyPr wrap="square" lIns="27432" rIns="27432" tIns="13716" bIns="13716" anchor="t">
-            <a:spAutoFit/>
-          </a:bodyPr>
-          <a:lstStyle/>
-          <a:p>
-            <a:pPr algn="l"/>
-            <a:r>
-              <a:rPr sz="1575" b="1" i="0">
-                <a:solidFill>
-                  <a:srgbClr val="7B5CF5"/>
-                </a:solidFill>
-                <a:latin typeface="Arial Black"/>
-              </a:rPr>
-              <a:t>② 改說明書(docstring)</a:t>
-            </a:r>
-          </a:p>
-        </p:txBody>
-      </p:sp>
-      <p:sp>
-        <p:nvSpPr>
           <p:cNvPr id="12" name="TextBox 11"/>
           <p:cNvSpPr txBox="1"/>
           <p:nvPr/>
         </p:nvSpPr>
         <p:spPr>
           <a:xfrm>
-            <a:off x="4972050" y="2366010"/>
-            <a:ext cx="3429000" cy="1028700"/>
+            <a:off x="3888485" y="2173986"/>
+            <a:ext cx="4491990" cy="1769364"/>
           </a:xfrm>
           <a:prstGeom prst="rect">
             <a:avLst/>
@@ -9693,65 +9784,97 @@
           <a:p>
             <a:pPr algn="l">
               <a:spcAft>
-                <a:spcPts val="600"/>
+                <a:spcPts val="75"/>
               </a:spcAft>
             </a:pPr>
             <a:r>
-              <a:rPr sz="1162" b="0" i="0">
-                <a:solidFill>
-                  <a:srgbClr val="374151"/>
-                </a:solidFill>
-                <a:latin typeface="Calibri"/>
-              </a:rPr>
-              <a:t>LLM 靠這段文字決定</a:t>
+              <a:rPr sz="1050" b="0" i="0">
+                <a:solidFill>
+                  <a:srgbClr val="A8E1B4"/>
+                </a:solidFill>
+                <a:latin typeface="Consolas"/>
+              </a:rPr>
+              <a:t>"""取得 XXX 研究室完整資訊。</a:t>
             </a:r>
           </a:p>
           <a:p>
             <a:pPr algn="l">
               <a:spcAft>
-                <a:spcPts val="600"/>
+                <a:spcPts val="75"/>
               </a:spcAft>
             </a:pPr>
             <a:r>
-              <a:rPr sz="1162" b="0" i="0">
-                <a:solidFill>
-                  <a:srgbClr val="374151"/>
-                </a:solidFill>
-                <a:latin typeface="Calibri"/>
-              </a:rPr>
-              <a:t>「要不要呼叫這支工具」</a:t>
+              <a:rPr sz="1050" b="0" i="0">
+                <a:solidFill>
+                  <a:srgbClr val="E5E7EB"/>
+                </a:solidFill>
+                <a:latin typeface="Consolas"/>
+              </a:rPr>
+              <a:t> </a:t>
             </a:r>
           </a:p>
           <a:p>
             <a:pPr algn="l">
               <a:spcAft>
-                <a:spcPts val="600"/>
+                <a:spcPts val="75"/>
               </a:spcAft>
             </a:pPr>
             <a:r>
-              <a:rPr sz="1162" b="0" i="0">
-                <a:solidFill>
-                  <a:srgbClr val="374151"/>
-                </a:solidFill>
-                <a:latin typeface="Calibri"/>
-              </a:rPr>
-              <a:t>寫清楚『使用情境』</a:t>
+              <a:rPr sz="1050" b="0" i="0">
+                <a:solidFill>
+                  <a:srgbClr val="A8E1B4"/>
+                </a:solidFill>
+                <a:latin typeface="Consolas"/>
+              </a:rPr>
+              <a:t>使用情境:使用者詢問研究方向、</a:t>
             </a:r>
           </a:p>
           <a:p>
             <a:pPr algn="l">
               <a:spcAft>
-                <a:spcPts val="600"/>
+                <a:spcPts val="75"/>
               </a:spcAft>
             </a:pPr>
             <a:r>
-              <a:rPr sz="1162" b="0" i="0">
-                <a:solidFill>
-                  <a:srgbClr val="374151"/>
-                </a:solidFill>
-                <a:latin typeface="Calibri"/>
-              </a:rPr>
-              <a:t>—— 它就知道何時該用</a:t>
+              <a:rPr sz="1050" b="0" i="0">
+                <a:solidFill>
+                  <a:srgbClr val="A8E1B4"/>
+                </a:solidFill>
+                <a:latin typeface="Consolas"/>
+              </a:rPr>
+              <a:t>PI 聯絡方式、招生名額時呼叫。</a:t>
+            </a:r>
+          </a:p>
+          <a:p>
+            <a:pPr algn="l">
+              <a:spcAft>
+                <a:spcPts val="75"/>
+              </a:spcAft>
+            </a:pPr>
+            <a:r>
+              <a:rPr sz="1050" b="0" i="0">
+                <a:solidFill>
+                  <a:srgbClr val="E5E7EB"/>
+                </a:solidFill>
+                <a:latin typeface="Consolas"/>
+              </a:rPr>
+              <a:t> </a:t>
+            </a:r>
+          </a:p>
+          <a:p>
+            <a:pPr algn="l">
+              <a:spcAft>
+                <a:spcPts val="75"/>
+              </a:spcAft>
+            </a:pPr>
+            <a:r>
+              <a:rPr sz="1050" b="0" i="0">
+                <a:solidFill>
+                  <a:srgbClr val="A8E1B4"/>
+                </a:solidFill>
+                <a:latin typeface="Consolas"/>
+              </a:rPr>
+              <a:t>回傳 JSON 字串。"""</a:t>
             </a:r>
           </a:p>
         </p:txBody>
@@ -9759,89 +9882,6 @@
       <p:sp>
         <p:nvSpPr>
           <p:cNvPr id="13" name="Rounded Rectangle 12"/>
-          <p:cNvSpPr/>
-          <p:nvPr/>
-        </p:nvSpPr>
-        <p:spPr>
-          <a:xfrm>
-            <a:off x="582930" y="3737610"/>
-            <a:ext cx="8229600" cy="377190"/>
-          </a:xfrm>
-          <a:prstGeom prst="roundRect">
-            <a:avLst>
-              <a:gd name="adj" fmla="val 10000"/>
-            </a:avLst>
-          </a:prstGeom>
-          <a:solidFill>
-            <a:srgbClr val="FFE7DB"/>
-          </a:solidFill>
-          <a:ln w="19050">
-            <a:solidFill>
-              <a:srgbClr val="FB7048"/>
-            </a:solidFill>
-          </a:ln>
-          <a:effectLst/>
-        </p:spPr>
-        <p:style>
-          <a:lnRef idx="1">
-            <a:schemeClr val="accent1"/>
-          </a:lnRef>
-          <a:fillRef idx="3">
-            <a:schemeClr val="accent1"/>
-          </a:fillRef>
-          <a:effectRef idx="2">
-            <a:schemeClr val="accent1"/>
-          </a:effectRef>
-          <a:fontRef idx="minor">
-            <a:schemeClr val="lt1"/>
-          </a:fontRef>
-        </p:style>
-        <p:txBody>
-          <a:bodyPr rtlCol="0" anchor="ctr"/>
-          <a:lstStyle/>
-          <a:p>
-            <a:pPr algn="ctr"/>
-          </a:p>
-        </p:txBody>
-      </p:sp>
-      <p:sp>
-        <p:nvSpPr>
-          <p:cNvPr id="14" name="TextBox 13"/>
-          <p:cNvSpPr txBox="1"/>
-          <p:nvPr/>
-        </p:nvSpPr>
-        <p:spPr>
-          <a:xfrm>
-            <a:off x="788669" y="3737610"/>
-            <a:ext cx="7818120" cy="377190"/>
-          </a:xfrm>
-          <a:prstGeom prst="rect">
-            <a:avLst/>
-          </a:prstGeom>
-          <a:noFill/>
-        </p:spPr>
-        <p:txBody>
-          <a:bodyPr wrap="square" lIns="27432" rIns="27432" tIns="13716" bIns="13716" anchor="ctr">
-            <a:spAutoFit/>
-          </a:bodyPr>
-          <a:lstStyle/>
-          <a:p>
-            <a:pPr algn="l"/>
-            <a:r>
-              <a:rPr sz="1050" b="1" i="0">
-                <a:solidFill>
-                  <a:srgbClr val="FB7048"/>
-                </a:solidFill>
-                <a:latin typeface="Calibri"/>
-              </a:rPr>
-              <a:t>▶  邏輯一行沒動,只換資料 + 說明書 —— 這就是 MCP 解耦的威力</a:t>
-            </a:r>
-          </a:p>
-        </p:txBody>
-      </p:sp>
-      <p:sp>
-        <p:nvSpPr>
-          <p:cNvPr id="15" name="Rounded Rectangle 14"/>
           <p:cNvSpPr/>
           <p:nvPr/>
         </p:nvSpPr>
@@ -9889,7 +9929,7 @@
       </p:sp>
       <p:sp>
         <p:nvSpPr>
-          <p:cNvPr id="16" name="TextBox 15"/>
+          <p:cNvPr id="14" name="TextBox 13"/>
           <p:cNvSpPr txBox="1"/>
           <p:nvPr/>
         </p:nvSpPr>
@@ -9917,14 +9957,14 @@
                 </a:solidFill>
                 <a:latin typeface="Calibri"/>
               </a:rPr>
-              <a:t>▶  切到 Colab　— 第 2 步：L1 ①換資料 → ②改 docstring → ③重啟驗證（學員必做）</a:t>
-            </a:r>
-          </a:p>
-        </p:txBody>
-      </p:sp>
-      <p:sp>
-        <p:nvSpPr>
-          <p:cNvPr id="17" name="TextBox 16"/>
+              <a:t>▶  切到 Colab　— 第 2 步：L1「換資料」→「改 docstring」→「重啟」（學員必做）</a:t>
+            </a:r>
+          </a:p>
+        </p:txBody>
+      </p:sp>
+      <p:sp>
+        <p:nvSpPr>
+          <p:cNvPr id="15" name="TextBox 14"/>
           <p:cNvSpPr txBox="1"/>
           <p:nvPr/>
         </p:nvSpPr>

</xml_diff>